<commit_message>
docs: bring the slides up to release 0.4.1
The testing slide shows the test counts after the hotfix, the release row
shows 0.4.1, and the environments card says which release is live.

Refs #16
</commit_message>
<xml_diff>
--- a/docs/task2/slides/toolshed-hire-task-2.pptx
+++ b/docs/task2/slides/toolshed-hire-task-2.pptx
@@ -121,19 +121,19 @@
   <p:extLst>
     <p:ext uri="{521415D9-36F7-43E2-AB2F-B90AF26B5E84}">
       <p14:sectionLst xmlns:p14="http://schemas.microsoft.com/office/powerpoint/2010/main">
-        <p14:section name="Opening" id="{893e9cc4-53d4-bb65-e48f-7836cf4c59dc}">
+        <p14:section name="Opening" id="{0fb5acc7-47e1-56c0-b488-12337f2771bf}">
           <p14:sldIdLst>
             <p14:sldId id="256"/>
           </p14:sldIdLst>
         </p14:section>
-        <p14:section name="The problem and the requirements" id="{5e7bfeb9-b3ab-5a91-a631-9c3577b78e56}">
+        <p14:section name="The problem and the requirements" id="{043fdbd7-bc97-2f5f-241c-7df38d7198ae}">
           <p14:sldIdLst>
             <p14:sldId id="257"/>
             <p14:sldId id="258"/>
             <p14:sldId id="259"/>
           </p14:sldIdLst>
         </p14:section>
-        <p14:section name="How it is built" id="{bad655a6-b7e6-a274-6188-81ace9376cf8}">
+        <p14:section name="How it is built" id="{5c7f082b-10e8-ea88-1d81-14575d9f9d14}">
           <p14:sldIdLst>
             <p14:sldId id="260"/>
             <p14:sldId id="261"/>
@@ -141,25 +141,25 @@
             <p14:sldId id="263"/>
           </p14:sldIdLst>
         </p14:section>
-        <p14:section name="How it is delivered" id="{9374f36d-ce39-22fc-cf4b-9942507ee6a9}">
+        <p14:section name="How it is delivered" id="{fd97d94b-0ff4-023b-5b91-969050f13a09}">
           <p14:sldIdLst>
             <p14:sldId id="264"/>
             <p14:sldId id="265"/>
           </p14:sldIdLst>
         </p14:section>
-        <p14:section name="Live demonstration" id="{6a05d273-67c9-9d3f-addc-8a5a5374b03b}">
+        <p14:section name="Live demonstration" id="{2c9eda83-7354-e3f6-bd62-30972ebe0555}">
           <p14:sldIdLst>
             <p14:sldId id="266"/>
           </p14:sldIdLst>
         </p14:section>
-        <p14:section name="Testing, deviations and what is next" id="{4a1e1ee0-0ce5-7103-4a17-0ad6726f0ccf}">
+        <p14:section name="Testing, deviations and what is next" id="{fa1e855b-89fb-3c12-8176-55fb3e370b3a}">
           <p14:sldIdLst>
             <p14:sldId id="267"/>
             <p14:sldId id="268"/>
             <p14:sldId id="269"/>
           </p14:sldIdLst>
         </p14:section>
-        <p14:section name="Close" id="{959c4aeb-f17c-7c90-4466-3183029ba054}">
+        <p14:section name="Close" id="{b2dbfc3a-88bf-2f2a-d52d-714c8155b66e}">
           <p14:sldIdLst>
             <p14:sldId id="270"/>
           </p14:sldIdLst>
@@ -6212,7 +6212,7 @@
                   <a:schemeClr val="tx1"/>
                 </a:solidFill>
               </a:rPr>
-              <a:t>4,618</a:t>
+              <a:t>4,623</a:t>
             </a:r>
             <a:endParaRPr lang="en-US" sz="3600" dirty="0"/>
           </a:p>
@@ -6424,7 +6424,7 @@
                   <a:schemeClr val="tx1"/>
                 </a:solidFill>
               </a:rPr>
-              <a:t>1,443</a:t>
+              <a:t>1,455</a:t>
             </a:r>
             <a:endParaRPr lang="en-US" sz="3600" dirty="0"/>
           </a:p>
@@ -9270,8 +9270,8 @@
         </p:nvSpPr>
         <p:spPr>
           <a:xfrm>
-            <a:off x="5105095" y="1865376"/>
-            <a:ext cx="822960" cy="292608"/>
+            <a:off x="5013655" y="1865376"/>
+            <a:ext cx="713232" cy="292608"/>
           </a:xfrm>
           <a:prstGeom prst="roundRect">
             <a:avLst>
@@ -9313,8 +9313,8 @@
         </p:nvSpPr>
         <p:spPr>
           <a:xfrm>
-            <a:off x="6019495" y="1865376"/>
-            <a:ext cx="822960" cy="292608"/>
+            <a:off x="5800039" y="1865376"/>
+            <a:ext cx="713232" cy="292608"/>
           </a:xfrm>
           <a:prstGeom prst="roundRect">
             <a:avLst>
@@ -9356,8 +9356,8 @@
         </p:nvSpPr>
         <p:spPr>
           <a:xfrm>
-            <a:off x="6933895" y="1865376"/>
-            <a:ext cx="822960" cy="292608"/>
+            <a:off x="6586423" y="1865376"/>
+            <a:ext cx="713232" cy="292608"/>
           </a:xfrm>
           <a:prstGeom prst="roundRect">
             <a:avLst>
@@ -9399,8 +9399,8 @@
         </p:nvSpPr>
         <p:spPr>
           <a:xfrm>
-            <a:off x="7848295" y="1865376"/>
-            <a:ext cx="822960" cy="292608"/>
+            <a:off x="7372807" y="1865376"/>
+            <a:ext cx="713232" cy="292608"/>
           </a:xfrm>
           <a:prstGeom prst="roundRect">
             <a:avLst>
@@ -9436,14 +9436,14 @@
       </p:sp>
       <p:sp>
         <p:nvSpPr>
-          <p:cNvPr id="11" name="Release task2-v1.0 626"/>
-          <p:cNvSpPr/>
-          <p:nvPr/>
-        </p:nvSpPr>
-        <p:spPr>
-          <a:xfrm>
-            <a:off x="8762695" y="1865376"/>
-            <a:ext cx="1097280" cy="292608"/>
+          <p:cNvPr id="11" name="Release v0.4.1 626"/>
+          <p:cNvSpPr/>
+          <p:nvPr/>
+        </p:nvSpPr>
+        <p:spPr>
+          <a:xfrm>
+            <a:off x="8159191" y="1865376"/>
+            <a:ext cx="713232" cy="292608"/>
           </a:xfrm>
           <a:prstGeom prst="roundRect">
             <a:avLst>
@@ -9451,7 +9451,7 @@
             </a:avLst>
           </a:prstGeom>
           <a:solidFill>
-            <a:schemeClr val="accent1"/>
+            <a:schemeClr val="tx1"/>
           </a:solidFill>
           <a:ln/>
         </p:spPr>
@@ -9463,14 +9463,57 @@
               <a:buNone/>
             </a:pPr>
             <a:r>
-              <a:rPr lang="en-US" sz="1100" b="1" dirty="0">
-                <a:solidFill>
-                  <a:schemeClr val="tx1"/>
+              <a:rPr lang="en-US" sz="1100" dirty="0">
+                <a:solidFill>
+                  <a:schemeClr val="bg1"/>
                 </a:solidFill>
                 <a:latin typeface="Consolas" pitchFamily="34" charset="0"/>
                 <a:ea typeface="Consolas" pitchFamily="34" charset="-122"/>
                 <a:cs typeface="Consolas" pitchFamily="34" charset="-120"/>
               </a:rPr>
+              <a:t>v0.4.1</a:t>
+            </a:r>
+            <a:endParaRPr lang="en-US" sz="1100" dirty="0"/>
+          </a:p>
+        </p:txBody>
+      </p:sp>
+      <p:sp>
+        <p:nvSpPr>
+          <p:cNvPr id="12" name="Release task2-v1.0 627"/>
+          <p:cNvSpPr/>
+          <p:nvPr/>
+        </p:nvSpPr>
+        <p:spPr>
+          <a:xfrm>
+            <a:off x="8945575" y="1865376"/>
+            <a:ext cx="1024128" cy="292608"/>
+          </a:xfrm>
+          <a:prstGeom prst="roundRect">
+            <a:avLst>
+              <a:gd name="adj" fmla="val 50000"/>
+            </a:avLst>
+          </a:prstGeom>
+          <a:solidFill>
+            <a:schemeClr val="accent1"/>
+          </a:solidFill>
+          <a:ln/>
+        </p:spPr>
+        <p:txBody>
+          <a:bodyPr wrap="square" lIns="25400" tIns="25400" rIns="25400" bIns="25400" rtlCol="0" anchor="ctr"/>
+          <a:lstStyle/>
+          <a:p>
+            <a:pPr algn="ctr" indent="0" marL="0">
+              <a:buNone/>
+            </a:pPr>
+            <a:r>
+              <a:rPr lang="en-US" sz="1100" b="1" dirty="0">
+                <a:solidFill>
+                  <a:schemeClr val="tx1"/>
+                </a:solidFill>
+                <a:latin typeface="Consolas" pitchFamily="34" charset="0"/>
+                <a:ea typeface="Consolas" pitchFamily="34" charset="-122"/>
+                <a:cs typeface="Consolas" pitchFamily="34" charset="-120"/>
+              </a:rPr>
               <a:t>task2-v1.0</a:t>
             </a:r>
             <a:endParaRPr lang="en-US" sz="1100" dirty="0"/>
@@ -9479,14 +9522,14 @@
       </p:sp>
       <p:sp>
         <p:nvSpPr>
-          <p:cNvPr id="12" name="Release v1.0.0 in Task 3 627"/>
-          <p:cNvSpPr/>
-          <p:nvPr/>
-        </p:nvSpPr>
-        <p:spPr>
-          <a:xfrm>
-            <a:off x="9951415" y="1865376"/>
-            <a:ext cx="1508760" cy="292608"/>
+          <p:cNvPr id="13" name="Release v1.0.0 in Task 3 628"/>
+          <p:cNvSpPr/>
+          <p:nvPr/>
+        </p:nvSpPr>
+        <p:spPr>
+          <a:xfrm>
+            <a:off x="10042855" y="1865376"/>
+            <a:ext cx="1417320" cy="292608"/>
           </a:xfrm>
           <a:prstGeom prst="roundRect">
             <a:avLst>
@@ -9527,7 +9570,7 @@
       </p:sp>
       <p:sp>
         <p:nvSpPr>
-          <p:cNvPr id="13" name="Branch 001 628"/>
+          <p:cNvPr id="14" name="Branch 001 629"/>
           <p:cNvSpPr/>
           <p:nvPr/>
         </p:nvSpPr>
@@ -9570,7 +9613,7 @@
       </p:sp>
       <p:sp>
         <p:nvSpPr>
-          <p:cNvPr id="14" name="Branch 002 629"/>
+          <p:cNvPr id="15" name="Branch 002 630"/>
           <p:cNvSpPr/>
           <p:nvPr/>
         </p:nvSpPr>
@@ -9613,7 +9656,7 @@
       </p:sp>
       <p:sp>
         <p:nvSpPr>
-          <p:cNvPr id="15" name="Branch 003 630"/>
+          <p:cNvPr id="16" name="Branch 003 631"/>
           <p:cNvSpPr/>
           <p:nvPr/>
         </p:nvSpPr>
@@ -9656,7 +9699,7 @@
       </p:sp>
       <p:sp>
         <p:nvSpPr>
-          <p:cNvPr id="16" name="Branch 004 631"/>
+          <p:cNvPr id="17" name="Branch 004 632"/>
           <p:cNvSpPr/>
           <p:nvPr/>
         </p:nvSpPr>
@@ -9699,7 +9742,7 @@
       </p:sp>
       <p:sp>
         <p:nvSpPr>
-          <p:cNvPr id="17" name="Branch 005 632"/>
+          <p:cNvPr id="18" name="Branch 005 633"/>
           <p:cNvSpPr/>
           <p:nvPr/>
         </p:nvSpPr>
@@ -9742,7 +9785,7 @@
       </p:sp>
       <p:sp>
         <p:nvSpPr>
-          <p:cNvPr id="18" name="Branch 006 633"/>
+          <p:cNvPr id="19" name="Branch 006 634"/>
           <p:cNvSpPr/>
           <p:nvPr/>
         </p:nvSpPr>
@@ -9785,7 +9828,7 @@
       </p:sp>
       <p:sp>
         <p:nvSpPr>
-          <p:cNvPr id="19" name="Branch 007 634"/>
+          <p:cNvPr id="20" name="Branch 007 635"/>
           <p:cNvSpPr/>
           <p:nvPr/>
         </p:nvSpPr>
@@ -9828,7 +9871,7 @@
       </p:sp>
       <p:sp>
         <p:nvSpPr>
-          <p:cNvPr id="20" name="Branch 008 635"/>
+          <p:cNvPr id="21" name="Branch 008 636"/>
           <p:cNvSpPr/>
           <p:nvPr/>
         </p:nvSpPr>
@@ -9871,7 +9914,7 @@
       </p:sp>
       <p:sp>
         <p:nvSpPr>
-          <p:cNvPr id="21" name="Branch 009 636"/>
+          <p:cNvPr id="22" name="Branch 009 637"/>
           <p:cNvSpPr/>
           <p:nvPr/>
         </p:nvSpPr>
@@ -9914,7 +9957,7 @@
       </p:sp>
       <p:sp>
         <p:nvSpPr>
-          <p:cNvPr id="22" name="Branch 010 637"/>
+          <p:cNvPr id="23" name="Branch 010 638"/>
           <p:cNvSpPr/>
           <p:nvPr/>
         </p:nvSpPr>
@@ -9957,7 +10000,7 @@
       </p:sp>
       <p:sp>
         <p:nvSpPr>
-          <p:cNvPr id="23" name="Branch 011 638"/>
+          <p:cNvPr id="24" name="Branch 011 639"/>
           <p:cNvSpPr/>
           <p:nvPr/>
         </p:nvSpPr>
@@ -10000,7 +10043,7 @@
       </p:sp>
       <p:sp>
         <p:nvSpPr>
-          <p:cNvPr id="24" name="Branch 012 639"/>
+          <p:cNvPr id="25" name="Branch 012 640"/>
           <p:cNvSpPr/>
           <p:nvPr/>
         </p:nvSpPr>
@@ -10043,7 +10086,7 @@
       </p:sp>
       <p:sp>
         <p:nvSpPr>
-          <p:cNvPr id="25" name="Branch 013 640"/>
+          <p:cNvPr id="26" name="Branch 013 641"/>
           <p:cNvSpPr/>
           <p:nvPr/>
         </p:nvSpPr>
@@ -10086,7 +10129,7 @@
       </p:sp>
       <p:sp>
         <p:nvSpPr>
-          <p:cNvPr id="26" name="Branch 014 641"/>
+          <p:cNvPr id="27" name="Branch 014 642"/>
           <p:cNvSpPr/>
           <p:nvPr/>
         </p:nvSpPr>
@@ -10129,7 +10172,7 @@
       </p:sp>
       <p:sp>
         <p:nvSpPr>
-          <p:cNvPr id="27" name="Branch 015 642"/>
+          <p:cNvPr id="28" name="Branch 015 643"/>
           <p:cNvSpPr/>
           <p:nvPr/>
         </p:nvSpPr>
@@ -10172,7 +10215,7 @@
       </p:sp>
       <p:sp>
         <p:nvSpPr>
-          <p:cNvPr id="28" name="Branch 016 643"/>
+          <p:cNvPr id="29" name="Branch 016 644"/>
           <p:cNvSpPr/>
           <p:nvPr/>
         </p:nvSpPr>
@@ -10215,7 +10258,7 @@
       </p:sp>
       <p:sp>
         <p:nvSpPr>
-          <p:cNvPr id="29" name="Branch 017 644"/>
+          <p:cNvPr id="30" name="Branch 017 645"/>
           <p:cNvSpPr/>
           <p:nvPr/>
         </p:nvSpPr>
@@ -10258,7 +10301,7 @@
       </p:sp>
       <p:sp>
         <p:nvSpPr>
-          <p:cNvPr id="30" name="Branch 018 645"/>
+          <p:cNvPr id="31" name="Branch 018 646"/>
           <p:cNvSpPr/>
           <p:nvPr/>
         </p:nvSpPr>
@@ -10301,7 +10344,7 @@
       </p:sp>
       <p:sp>
         <p:nvSpPr>
-          <p:cNvPr id="31" name="Branch 019 646"/>
+          <p:cNvPr id="32" name="Branch 019 647"/>
           <p:cNvSpPr/>
           <p:nvPr/>
         </p:nvSpPr>
@@ -10344,7 +10387,7 @@
       </p:sp>
       <p:sp>
         <p:nvSpPr>
-          <p:cNvPr id="32" name="Branch 020 647"/>
+          <p:cNvPr id="33" name="Branch 020 648"/>
           <p:cNvSpPr/>
           <p:nvPr/>
         </p:nvSpPr>
@@ -10387,7 +10430,7 @@
       </p:sp>
       <p:sp>
         <p:nvSpPr>
-          <p:cNvPr id="33" name="Branch 021 648"/>
+          <p:cNvPr id="34" name="Branch 021 649"/>
           <p:cNvSpPr/>
           <p:nvPr/>
         </p:nvSpPr>
@@ -10430,7 +10473,7 @@
       </p:sp>
       <p:sp>
         <p:nvSpPr>
-          <p:cNvPr id="34" name="Branch 022 649"/>
+          <p:cNvPr id="35" name="Branch 022 650"/>
           <p:cNvSpPr/>
           <p:nvPr/>
         </p:nvSpPr>
@@ -10473,7 +10516,7 @@
       </p:sp>
       <p:sp>
         <p:nvSpPr>
-          <p:cNvPr id="35" name="Card 650"/>
+          <p:cNvPr id="36" name="Card 651"/>
           <p:cNvSpPr/>
           <p:nvPr/>
         </p:nvSpPr>
@@ -10507,7 +10550,7 @@
       </p:sp>
       <p:sp>
         <p:nvSpPr>
-          <p:cNvPr id="36" name="Icon doc 651"/>
+          <p:cNvPr id="37" name="Icon doc 652"/>
           <p:cNvSpPr/>
           <p:nvPr/>
         </p:nvSpPr>
@@ -10527,7 +10570,7 @@
       </p:sp>
       <p:sp>
         <p:nvSpPr>
-          <p:cNvPr id="37" name="Glyph part 653"/>
+          <p:cNvPr id="38" name="Glyph part 654"/>
           <p:cNvSpPr/>
           <p:nvPr/>
         </p:nvSpPr>
@@ -10547,7 +10590,7 @@
       </p:sp>
       <p:sp>
         <p:nvSpPr>
-          <p:cNvPr id="38" name="Glyph part 654"/>
+          <p:cNvPr id="39" name="Glyph part 655"/>
           <p:cNvSpPr/>
           <p:nvPr/>
         </p:nvSpPr>
@@ -10567,7 +10610,7 @@
       </p:sp>
       <p:sp>
         <p:nvSpPr>
-          <p:cNvPr id="39" name="Glyph part 655"/>
+          <p:cNvPr id="40" name="Glyph part 656"/>
           <p:cNvSpPr/>
           <p:nvPr/>
         </p:nvSpPr>
@@ -10587,7 +10630,7 @@
       </p:sp>
       <p:sp>
         <p:nvSpPr>
-          <p:cNvPr id="40" name="Text 656"/>
+          <p:cNvPr id="41" name="Text 657"/>
           <p:cNvSpPr txBox="1"/>
           <p:nvPr/>
         </p:nvSpPr>
@@ -10623,7 +10666,7 @@
       </p:sp>
       <p:sp>
         <p:nvSpPr>
-          <p:cNvPr id="41" name="Text 657"/>
+          <p:cNvPr id="42" name="Text 658"/>
           <p:cNvSpPr txBox="1"/>
           <p:nvPr/>
         </p:nvSpPr>
@@ -10659,7 +10702,7 @@
       </p:sp>
       <p:sp>
         <p:nvSpPr>
-          <p:cNvPr id="42" name="Card 658"/>
+          <p:cNvPr id="43" name="Card 659"/>
           <p:cNvSpPr/>
           <p:nvPr/>
         </p:nvSpPr>
@@ -10693,7 +10736,7 @@
       </p:sp>
       <p:sp>
         <p:nvSpPr>
-          <p:cNvPr id="43" name="Icon camera 659"/>
+          <p:cNvPr id="44" name="Icon camera 660"/>
           <p:cNvSpPr/>
           <p:nvPr/>
         </p:nvSpPr>
@@ -10713,7 +10756,7 @@
       </p:sp>
       <p:sp>
         <p:nvSpPr>
-          <p:cNvPr id="44" name="Glyph part 661"/>
+          <p:cNvPr id="45" name="Glyph part 662"/>
           <p:cNvSpPr/>
           <p:nvPr/>
         </p:nvSpPr>
@@ -10733,7 +10776,7 @@
       </p:sp>
       <p:sp>
         <p:nvSpPr>
-          <p:cNvPr id="45" name="Glyph part 662"/>
+          <p:cNvPr id="46" name="Glyph part 663"/>
           <p:cNvSpPr/>
           <p:nvPr/>
         </p:nvSpPr>
@@ -10755,7 +10798,7 @@
       </p:sp>
       <p:sp>
         <p:nvSpPr>
-          <p:cNvPr id="46" name="Glyph part 663"/>
+          <p:cNvPr id="47" name="Glyph part 664"/>
           <p:cNvSpPr/>
           <p:nvPr/>
         </p:nvSpPr>
@@ -10775,7 +10818,7 @@
       </p:sp>
       <p:sp>
         <p:nvSpPr>
-          <p:cNvPr id="47" name="Glyph part 664"/>
+          <p:cNvPr id="48" name="Glyph part 665"/>
           <p:cNvSpPr/>
           <p:nvPr/>
         </p:nvSpPr>
@@ -10795,7 +10838,7 @@
       </p:sp>
       <p:sp>
         <p:nvSpPr>
-          <p:cNvPr id="48" name="Text 665"/>
+          <p:cNvPr id="49" name="Text 666"/>
           <p:cNvSpPr txBox="1"/>
           <p:nvPr/>
         </p:nvSpPr>
@@ -10831,7 +10874,7 @@
       </p:sp>
       <p:sp>
         <p:nvSpPr>
-          <p:cNvPr id="49" name="Text 666"/>
+          <p:cNvPr id="50" name="Text 667"/>
           <p:cNvSpPr txBox="1"/>
           <p:nvPr/>
         </p:nvSpPr>
@@ -10867,7 +10910,7 @@
       </p:sp>
       <p:sp>
         <p:nvSpPr>
-          <p:cNvPr id="50" name="Card 667"/>
+          <p:cNvPr id="51" name="Card 668"/>
           <p:cNvSpPr/>
           <p:nvPr/>
         </p:nvSpPr>
@@ -10901,7 +10944,7 @@
       </p:sp>
       <p:sp>
         <p:nvSpPr>
-          <p:cNvPr id="51" name="Icon clock 668"/>
+          <p:cNvPr id="52" name="Icon clock 669"/>
           <p:cNvSpPr/>
           <p:nvPr/>
         </p:nvSpPr>
@@ -10921,7 +10964,7 @@
       </p:sp>
       <p:sp>
         <p:nvSpPr>
-          <p:cNvPr id="52" name="Glyph part 670"/>
+          <p:cNvPr id="53" name="Glyph part 671"/>
           <p:cNvSpPr/>
           <p:nvPr/>
         </p:nvSpPr>
@@ -10944,7 +10987,7 @@
       </p:sp>
       <p:sp>
         <p:nvSpPr>
-          <p:cNvPr id="53" name="Glyph stroke 671"/>
+          <p:cNvPr id="54" name="Glyph stroke 672"/>
           <p:cNvSpPr/>
           <p:nvPr/>
         </p:nvSpPr>
@@ -10967,7 +11010,7 @@
       </p:sp>
       <p:sp>
         <p:nvSpPr>
-          <p:cNvPr id="54" name="Glyph stroke 672"/>
+          <p:cNvPr id="55" name="Glyph stroke 673"/>
           <p:cNvSpPr/>
           <p:nvPr/>
         </p:nvSpPr>
@@ -10990,7 +11033,7 @@
       </p:sp>
       <p:sp>
         <p:nvSpPr>
-          <p:cNvPr id="55" name="Text 673"/>
+          <p:cNvPr id="56" name="Text 674"/>
           <p:cNvSpPr txBox="1"/>
           <p:nvPr/>
         </p:nvSpPr>
@@ -11026,7 +11069,7 @@
       </p:sp>
       <p:sp>
         <p:nvSpPr>
-          <p:cNvPr id="56" name="Text 674"/>
+          <p:cNvPr id="57" name="Text 675"/>
           <p:cNvSpPr txBox="1"/>
           <p:nvPr/>
         </p:nvSpPr>
@@ -11062,7 +11105,7 @@
       </p:sp>
       <p:sp>
         <p:nvSpPr>
-          <p:cNvPr id="57" name="Card 675"/>
+          <p:cNvPr id="58" name="Card 676"/>
           <p:cNvSpPr/>
           <p:nvPr/>
         </p:nvSpPr>
@@ -11096,7 +11139,7 @@
       </p:sp>
       <p:sp>
         <p:nvSpPr>
-          <p:cNvPr id="58" name="Icon bolt 676"/>
+          <p:cNvPr id="59" name="Icon bolt 677"/>
           <p:cNvSpPr/>
           <p:nvPr/>
         </p:nvSpPr>
@@ -11116,7 +11159,7 @@
       </p:sp>
       <p:sp>
         <p:nvSpPr>
-          <p:cNvPr id="59" name="Glyph part 678"/>
+          <p:cNvPr id="60" name="Glyph part 679"/>
           <p:cNvSpPr/>
           <p:nvPr/>
         </p:nvSpPr>
@@ -11136,7 +11179,7 @@
       </p:sp>
       <p:sp>
         <p:nvSpPr>
-          <p:cNvPr id="60" name="Text 679"/>
+          <p:cNvPr id="61" name="Text 680"/>
           <p:cNvSpPr txBox="1"/>
           <p:nvPr/>
         </p:nvSpPr>
@@ -11172,7 +11215,7 @@
       </p:sp>
       <p:sp>
         <p:nvSpPr>
-          <p:cNvPr id="61" name="Text 680"/>
+          <p:cNvPr id="62" name="Text 681"/>
           <p:cNvSpPr txBox="1"/>
           <p:nvPr/>
         </p:nvSpPr>
@@ -11208,7 +11251,7 @@
       </p:sp>
       <p:sp>
         <p:nvSpPr>
-          <p:cNvPr id="62" name="Card 681"/>
+          <p:cNvPr id="63" name="Card 682"/>
           <p:cNvSpPr/>
           <p:nvPr/>
         </p:nvSpPr>
@@ -11242,7 +11285,7 @@
       </p:sp>
       <p:sp>
         <p:nvSpPr>
-          <p:cNvPr id="63" name="Icon tag 682"/>
+          <p:cNvPr id="64" name="Icon tag 683"/>
           <p:cNvSpPr/>
           <p:nvPr/>
         </p:nvSpPr>
@@ -11262,7 +11305,7 @@
       </p:sp>
       <p:sp>
         <p:nvSpPr>
-          <p:cNvPr id="64" name="Glyph part 684"/>
+          <p:cNvPr id="65" name="Glyph part 685"/>
           <p:cNvSpPr/>
           <p:nvPr/>
         </p:nvSpPr>
@@ -11282,7 +11325,7 @@
       </p:sp>
       <p:sp>
         <p:nvSpPr>
-          <p:cNvPr id="65" name="Glyph part 685"/>
+          <p:cNvPr id="66" name="Glyph part 686"/>
           <p:cNvSpPr/>
           <p:nvPr/>
         </p:nvSpPr>
@@ -11302,7 +11345,7 @@
       </p:sp>
       <p:sp>
         <p:nvSpPr>
-          <p:cNvPr id="66" name="Text 686"/>
+          <p:cNvPr id="67" name="Text 687"/>
           <p:cNvSpPr txBox="1"/>
           <p:nvPr/>
         </p:nvSpPr>
@@ -11338,7 +11381,7 @@
       </p:sp>
       <p:sp>
         <p:nvSpPr>
-          <p:cNvPr id="67" name="Text 687"/>
+          <p:cNvPr id="68" name="Text 688"/>
           <p:cNvSpPr txBox="1"/>
           <p:nvPr/>
         </p:nvSpPr>
@@ -11482,7 +11525,7 @@
       </p:sp>
       <p:sp>
         <p:nvSpPr>
-          <p:cNvPr id="4" name="Icon browser 688"/>
+          <p:cNvPr id="4" name="Icon browser 689"/>
           <p:cNvSpPr/>
           <p:nvPr/>
         </p:nvSpPr>
@@ -11502,7 +11545,7 @@
       </p:sp>
       <p:sp>
         <p:nvSpPr>
-          <p:cNvPr id="5" name="Glyph part 690"/>
+          <p:cNvPr id="5" name="Glyph part 691"/>
           <p:cNvSpPr/>
           <p:nvPr/>
         </p:nvSpPr>
@@ -11525,7 +11568,7 @@
       </p:sp>
       <p:sp>
         <p:nvSpPr>
-          <p:cNvPr id="6" name="Glyph part 691"/>
+          <p:cNvPr id="6" name="Glyph part 692"/>
           <p:cNvSpPr/>
           <p:nvPr/>
         </p:nvSpPr>
@@ -11545,7 +11588,7 @@
       </p:sp>
       <p:sp>
         <p:nvSpPr>
-          <p:cNvPr id="7" name="Text 692"/>
+          <p:cNvPr id="7" name="Text 693"/>
           <p:cNvSpPr txBox="1"/>
           <p:nvPr/>
         </p:nvSpPr>
@@ -11581,7 +11624,7 @@
       </p:sp>
       <p:sp>
         <p:nvSpPr>
-          <p:cNvPr id="8" name="Icon branch 693"/>
+          <p:cNvPr id="8" name="Icon branch 694"/>
           <p:cNvSpPr/>
           <p:nvPr/>
         </p:nvSpPr>
@@ -11601,7 +11644,7 @@
       </p:sp>
       <p:sp>
         <p:nvSpPr>
-          <p:cNvPr id="9" name="Glyph stroke 695"/>
+          <p:cNvPr id="9" name="Glyph stroke 696"/>
           <p:cNvSpPr/>
           <p:nvPr/>
         </p:nvSpPr>
@@ -11624,7 +11667,7 @@
       </p:sp>
       <p:sp>
         <p:nvSpPr>
-          <p:cNvPr id="10" name="Glyph stroke 696"/>
+          <p:cNvPr id="10" name="Glyph stroke 697"/>
           <p:cNvSpPr/>
           <p:nvPr/>
         </p:nvSpPr>
@@ -11647,7 +11690,7 @@
       </p:sp>
       <p:sp>
         <p:nvSpPr>
-          <p:cNvPr id="11" name="Glyph part 697"/>
+          <p:cNvPr id="11" name="Glyph part 698"/>
           <p:cNvSpPr/>
           <p:nvPr/>
         </p:nvSpPr>
@@ -11667,7 +11710,7 @@
       </p:sp>
       <p:sp>
         <p:nvSpPr>
-          <p:cNvPr id="12" name="Glyph part 698"/>
+          <p:cNvPr id="12" name="Glyph part 699"/>
           <p:cNvSpPr/>
           <p:nvPr/>
         </p:nvSpPr>
@@ -11687,7 +11730,7 @@
       </p:sp>
       <p:sp>
         <p:nvSpPr>
-          <p:cNvPr id="13" name="Glyph part 699"/>
+          <p:cNvPr id="13" name="Glyph part 700"/>
           <p:cNvSpPr/>
           <p:nvPr/>
         </p:nvSpPr>
@@ -11707,7 +11750,7 @@
       </p:sp>
       <p:sp>
         <p:nvSpPr>
-          <p:cNvPr id="14" name="Text 700"/>
+          <p:cNvPr id="14" name="Text 701"/>
           <p:cNvSpPr txBox="1"/>
           <p:nvPr/>
         </p:nvSpPr>
@@ -11743,7 +11786,7 @@
       </p:sp>
       <p:sp>
         <p:nvSpPr>
-          <p:cNvPr id="15" name="Icon person 701"/>
+          <p:cNvPr id="15" name="Icon person 702"/>
           <p:cNvSpPr/>
           <p:nvPr/>
         </p:nvSpPr>
@@ -11763,7 +11806,7 @@
       </p:sp>
       <p:sp>
         <p:nvSpPr>
-          <p:cNvPr id="16" name="Glyph part 703"/>
+          <p:cNvPr id="16" name="Glyph part 704"/>
           <p:cNvSpPr/>
           <p:nvPr/>
         </p:nvSpPr>
@@ -11783,7 +11826,7 @@
       </p:sp>
       <p:sp>
         <p:nvSpPr>
-          <p:cNvPr id="17" name="Glyph part 704"/>
+          <p:cNvPr id="17" name="Glyph part 705"/>
           <p:cNvSpPr/>
           <p:nvPr/>
         </p:nvSpPr>
@@ -11803,7 +11846,7 @@
       </p:sp>
       <p:sp>
         <p:nvSpPr>
-          <p:cNvPr id="18" name="Text 705"/>
+          <p:cNvPr id="18" name="Text 706"/>
           <p:cNvSpPr txBox="1"/>
           <p:nvPr/>
         </p:nvSpPr>
@@ -11839,7 +11882,7 @@
       </p:sp>
       <p:sp>
         <p:nvSpPr>
-          <p:cNvPr id="19" name="Text 706"/>
+          <p:cNvPr id="19" name="Text 707"/>
           <p:cNvSpPr txBox="1"/>
           <p:nvPr/>
         </p:nvSpPr>
@@ -15005,7 +15048,7 @@
                   <a:schemeClr val="tx2"/>
                 </a:solidFill>
               </a:rPr>
-              <a:t>Deployed by the pipeline only, and released as v0.4.0</a:t>
+              <a:t>Deployed by the pipeline only, and live as v0.4.1</a:t>
             </a:r>
             <a:endParaRPr lang="en-US" sz="1400" dirty="0"/>
           </a:p>

</xml_diff>

<commit_message>
docs: bring the slides up to release 0.4.2
The testing slide shows 1,458 frontend tests, the release row shows 0.4.2,
and the environments card says 0.4.2 is live.

Refs #16
</commit_message>
<xml_diff>
--- a/docs/task2/slides/toolshed-hire-task-2.pptx
+++ b/docs/task2/slides/toolshed-hire-task-2.pptx
@@ -121,19 +121,19 @@
   <p:extLst>
     <p:ext uri="{521415D9-36F7-43E2-AB2F-B90AF26B5E84}">
       <p14:sectionLst xmlns:p14="http://schemas.microsoft.com/office/powerpoint/2010/main">
-        <p14:section name="Opening" id="{0fb5acc7-47e1-56c0-b488-12337f2771bf}">
+        <p14:section name="Opening" id="{5376035e-6469-292c-a912-edd4867daf5d}">
           <p14:sldIdLst>
             <p14:sldId id="256"/>
           </p14:sldIdLst>
         </p14:section>
-        <p14:section name="The problem and the requirements" id="{043fdbd7-bc97-2f5f-241c-7df38d7198ae}">
+        <p14:section name="The problem and the requirements" id="{b41b85d0-b771-864c-1d19-9778dec81a5b}">
           <p14:sldIdLst>
             <p14:sldId id="257"/>
             <p14:sldId id="258"/>
             <p14:sldId id="259"/>
           </p14:sldIdLst>
         </p14:section>
-        <p14:section name="How it is built" id="{5c7f082b-10e8-ea88-1d81-14575d9f9d14}">
+        <p14:section name="How it is built" id="{dc2f565a-a945-92c1-0abb-ca5b8f484f53}">
           <p14:sldIdLst>
             <p14:sldId id="260"/>
             <p14:sldId id="261"/>
@@ -141,25 +141,25 @@
             <p14:sldId id="263"/>
           </p14:sldIdLst>
         </p14:section>
-        <p14:section name="How it is delivered" id="{fd97d94b-0ff4-023b-5b91-969050f13a09}">
+        <p14:section name="How it is delivered" id="{6d7738be-29f7-ca2f-df81-e6cd39c133e4}">
           <p14:sldIdLst>
             <p14:sldId id="264"/>
             <p14:sldId id="265"/>
           </p14:sldIdLst>
         </p14:section>
-        <p14:section name="Live demonstration" id="{2c9eda83-7354-e3f6-bd62-30972ebe0555}">
+        <p14:section name="Live demonstration" id="{f6801cd3-cfea-889c-ed6c-5868e2153918}">
           <p14:sldIdLst>
             <p14:sldId id="266"/>
           </p14:sldIdLst>
         </p14:section>
-        <p14:section name="Testing, deviations and what is next" id="{fa1e855b-89fb-3c12-8176-55fb3e370b3a}">
+        <p14:section name="Testing, deviations and what is next" id="{1cda5166-4716-e867-910d-0230dd2ce42e}">
           <p14:sldIdLst>
             <p14:sldId id="267"/>
             <p14:sldId id="268"/>
             <p14:sldId id="269"/>
           </p14:sldIdLst>
         </p14:section>
-        <p14:section name="Close" id="{b2dbfc3a-88bf-2f2a-d52d-714c8155b66e}">
+        <p14:section name="Close" id="{c4a315ea-24d6-aca7-53d4-a69afb4c7c37}">
           <p14:sldIdLst>
             <p14:sldId id="270"/>
           </p14:sldIdLst>
@@ -6424,7 +6424,7 @@
                   <a:schemeClr val="tx1"/>
                 </a:solidFill>
               </a:rPr>
-              <a:t>1,455</a:t>
+              <a:t>1,458</a:t>
             </a:r>
             <a:endParaRPr lang="en-US" sz="3600" dirty="0"/>
           </a:p>
@@ -9270,8 +9270,8 @@
         </p:nvSpPr>
         <p:spPr>
           <a:xfrm>
-            <a:off x="5013655" y="1865376"/>
-            <a:ext cx="713232" cy="292608"/>
+            <a:off x="4638751" y="1865376"/>
+            <a:ext cx="658368" cy="292608"/>
           </a:xfrm>
           <a:prstGeom prst="roundRect">
             <a:avLst>
@@ -9313,8 +9313,8 @@
         </p:nvSpPr>
         <p:spPr>
           <a:xfrm>
-            <a:off x="5800039" y="1865376"/>
-            <a:ext cx="713232" cy="292608"/>
+            <a:off x="5370271" y="1865376"/>
+            <a:ext cx="658368" cy="292608"/>
           </a:xfrm>
           <a:prstGeom prst="roundRect">
             <a:avLst>
@@ -9356,8 +9356,8 @@
         </p:nvSpPr>
         <p:spPr>
           <a:xfrm>
-            <a:off x="6586423" y="1865376"/>
-            <a:ext cx="713232" cy="292608"/>
+            <a:off x="6101791" y="1865376"/>
+            <a:ext cx="658368" cy="292608"/>
           </a:xfrm>
           <a:prstGeom prst="roundRect">
             <a:avLst>
@@ -9399,8 +9399,8 @@
         </p:nvSpPr>
         <p:spPr>
           <a:xfrm>
-            <a:off x="7372807" y="1865376"/>
-            <a:ext cx="713232" cy="292608"/>
+            <a:off x="6833311" y="1865376"/>
+            <a:ext cx="658368" cy="292608"/>
           </a:xfrm>
           <a:prstGeom prst="roundRect">
             <a:avLst>
@@ -9442,8 +9442,8 @@
         </p:nvSpPr>
         <p:spPr>
           <a:xfrm>
-            <a:off x="8159191" y="1865376"/>
-            <a:ext cx="713232" cy="292608"/>
+            <a:off x="7564831" y="1865376"/>
+            <a:ext cx="658368" cy="292608"/>
           </a:xfrm>
           <a:prstGeom prst="roundRect">
             <a:avLst>
@@ -9479,14 +9479,14 @@
       </p:sp>
       <p:sp>
         <p:nvSpPr>
-          <p:cNvPr id="12" name="Release task2-v1.0 627"/>
-          <p:cNvSpPr/>
-          <p:nvPr/>
-        </p:nvSpPr>
-        <p:spPr>
-          <a:xfrm>
-            <a:off x="8945575" y="1865376"/>
-            <a:ext cx="1024128" cy="292608"/>
+          <p:cNvPr id="12" name="Release v0.4.2 627"/>
+          <p:cNvSpPr/>
+          <p:nvPr/>
+        </p:nvSpPr>
+        <p:spPr>
+          <a:xfrm>
+            <a:off x="8296351" y="1865376"/>
+            <a:ext cx="658368" cy="292608"/>
           </a:xfrm>
           <a:prstGeom prst="roundRect">
             <a:avLst>
@@ -9494,7 +9494,7 @@
             </a:avLst>
           </a:prstGeom>
           <a:solidFill>
-            <a:schemeClr val="accent1"/>
+            <a:schemeClr val="tx1"/>
           </a:solidFill>
           <a:ln/>
         </p:spPr>
@@ -9506,14 +9506,57 @@
               <a:buNone/>
             </a:pPr>
             <a:r>
-              <a:rPr lang="en-US" sz="1100" b="1" dirty="0">
-                <a:solidFill>
-                  <a:schemeClr val="tx1"/>
+              <a:rPr lang="en-US" sz="1100" dirty="0">
+                <a:solidFill>
+                  <a:schemeClr val="bg1"/>
                 </a:solidFill>
                 <a:latin typeface="Consolas" pitchFamily="34" charset="0"/>
                 <a:ea typeface="Consolas" pitchFamily="34" charset="-122"/>
                 <a:cs typeface="Consolas" pitchFamily="34" charset="-120"/>
               </a:rPr>
+              <a:t>v0.4.2</a:t>
+            </a:r>
+            <a:endParaRPr lang="en-US" sz="1100" dirty="0"/>
+          </a:p>
+        </p:txBody>
+      </p:sp>
+      <p:sp>
+        <p:nvSpPr>
+          <p:cNvPr id="13" name="Release task2-v1.0 628"/>
+          <p:cNvSpPr/>
+          <p:nvPr/>
+        </p:nvSpPr>
+        <p:spPr>
+          <a:xfrm>
+            <a:off x="9027871" y="1865376"/>
+            <a:ext cx="987552" cy="292608"/>
+          </a:xfrm>
+          <a:prstGeom prst="roundRect">
+            <a:avLst>
+              <a:gd name="adj" fmla="val 50000"/>
+            </a:avLst>
+          </a:prstGeom>
+          <a:solidFill>
+            <a:schemeClr val="accent1"/>
+          </a:solidFill>
+          <a:ln/>
+        </p:spPr>
+        <p:txBody>
+          <a:bodyPr wrap="square" lIns="25400" tIns="25400" rIns="25400" bIns="25400" rtlCol="0" anchor="ctr"/>
+          <a:lstStyle/>
+          <a:p>
+            <a:pPr algn="ctr" indent="0" marL="0">
+              <a:buNone/>
+            </a:pPr>
+            <a:r>
+              <a:rPr lang="en-US" sz="1100" b="1" dirty="0">
+                <a:solidFill>
+                  <a:schemeClr val="tx1"/>
+                </a:solidFill>
+                <a:latin typeface="Consolas" pitchFamily="34" charset="0"/>
+                <a:ea typeface="Consolas" pitchFamily="34" charset="-122"/>
+                <a:cs typeface="Consolas" pitchFamily="34" charset="-120"/>
+              </a:rPr>
               <a:t>task2-v1.0</a:t>
             </a:r>
             <a:endParaRPr lang="en-US" sz="1100" dirty="0"/>
@@ -9522,14 +9565,14 @@
       </p:sp>
       <p:sp>
         <p:nvSpPr>
-          <p:cNvPr id="13" name="Release v1.0.0 in Task 3 628"/>
-          <p:cNvSpPr/>
-          <p:nvPr/>
-        </p:nvSpPr>
-        <p:spPr>
-          <a:xfrm>
-            <a:off x="10042855" y="1865376"/>
-            <a:ext cx="1417320" cy="292608"/>
+          <p:cNvPr id="14" name="Release v1.0.0 in Task 3 629"/>
+          <p:cNvSpPr/>
+          <p:nvPr/>
+        </p:nvSpPr>
+        <p:spPr>
+          <a:xfrm>
+            <a:off x="10088575" y="1865376"/>
+            <a:ext cx="1371600" cy="292608"/>
           </a:xfrm>
           <a:prstGeom prst="roundRect">
             <a:avLst>
@@ -9570,7 +9613,7 @@
       </p:sp>
       <p:sp>
         <p:nvSpPr>
-          <p:cNvPr id="14" name="Branch 001 629"/>
+          <p:cNvPr id="15" name="Branch 001 630"/>
           <p:cNvSpPr/>
           <p:nvPr/>
         </p:nvSpPr>
@@ -9613,7 +9656,7 @@
       </p:sp>
       <p:sp>
         <p:nvSpPr>
-          <p:cNvPr id="15" name="Branch 002 630"/>
+          <p:cNvPr id="16" name="Branch 002 631"/>
           <p:cNvSpPr/>
           <p:nvPr/>
         </p:nvSpPr>
@@ -9656,7 +9699,7 @@
       </p:sp>
       <p:sp>
         <p:nvSpPr>
-          <p:cNvPr id="16" name="Branch 003 631"/>
+          <p:cNvPr id="17" name="Branch 003 632"/>
           <p:cNvSpPr/>
           <p:nvPr/>
         </p:nvSpPr>
@@ -9699,7 +9742,7 @@
       </p:sp>
       <p:sp>
         <p:nvSpPr>
-          <p:cNvPr id="17" name="Branch 004 632"/>
+          <p:cNvPr id="18" name="Branch 004 633"/>
           <p:cNvSpPr/>
           <p:nvPr/>
         </p:nvSpPr>
@@ -9742,7 +9785,7 @@
       </p:sp>
       <p:sp>
         <p:nvSpPr>
-          <p:cNvPr id="18" name="Branch 005 633"/>
+          <p:cNvPr id="19" name="Branch 005 634"/>
           <p:cNvSpPr/>
           <p:nvPr/>
         </p:nvSpPr>
@@ -9785,7 +9828,7 @@
       </p:sp>
       <p:sp>
         <p:nvSpPr>
-          <p:cNvPr id="19" name="Branch 006 634"/>
+          <p:cNvPr id="20" name="Branch 006 635"/>
           <p:cNvSpPr/>
           <p:nvPr/>
         </p:nvSpPr>
@@ -9828,7 +9871,7 @@
       </p:sp>
       <p:sp>
         <p:nvSpPr>
-          <p:cNvPr id="20" name="Branch 007 635"/>
+          <p:cNvPr id="21" name="Branch 007 636"/>
           <p:cNvSpPr/>
           <p:nvPr/>
         </p:nvSpPr>
@@ -9871,7 +9914,7 @@
       </p:sp>
       <p:sp>
         <p:nvSpPr>
-          <p:cNvPr id="21" name="Branch 008 636"/>
+          <p:cNvPr id="22" name="Branch 008 637"/>
           <p:cNvSpPr/>
           <p:nvPr/>
         </p:nvSpPr>
@@ -9914,7 +9957,7 @@
       </p:sp>
       <p:sp>
         <p:nvSpPr>
-          <p:cNvPr id="22" name="Branch 009 637"/>
+          <p:cNvPr id="23" name="Branch 009 638"/>
           <p:cNvSpPr/>
           <p:nvPr/>
         </p:nvSpPr>
@@ -9957,7 +10000,7 @@
       </p:sp>
       <p:sp>
         <p:nvSpPr>
-          <p:cNvPr id="23" name="Branch 010 638"/>
+          <p:cNvPr id="24" name="Branch 010 639"/>
           <p:cNvSpPr/>
           <p:nvPr/>
         </p:nvSpPr>
@@ -10000,7 +10043,7 @@
       </p:sp>
       <p:sp>
         <p:nvSpPr>
-          <p:cNvPr id="24" name="Branch 011 639"/>
+          <p:cNvPr id="25" name="Branch 011 640"/>
           <p:cNvSpPr/>
           <p:nvPr/>
         </p:nvSpPr>
@@ -10043,7 +10086,7 @@
       </p:sp>
       <p:sp>
         <p:nvSpPr>
-          <p:cNvPr id="25" name="Branch 012 640"/>
+          <p:cNvPr id="26" name="Branch 012 641"/>
           <p:cNvSpPr/>
           <p:nvPr/>
         </p:nvSpPr>
@@ -10086,7 +10129,7 @@
       </p:sp>
       <p:sp>
         <p:nvSpPr>
-          <p:cNvPr id="26" name="Branch 013 641"/>
+          <p:cNvPr id="27" name="Branch 013 642"/>
           <p:cNvSpPr/>
           <p:nvPr/>
         </p:nvSpPr>
@@ -10129,7 +10172,7 @@
       </p:sp>
       <p:sp>
         <p:nvSpPr>
-          <p:cNvPr id="27" name="Branch 014 642"/>
+          <p:cNvPr id="28" name="Branch 014 643"/>
           <p:cNvSpPr/>
           <p:nvPr/>
         </p:nvSpPr>
@@ -10172,7 +10215,7 @@
       </p:sp>
       <p:sp>
         <p:nvSpPr>
-          <p:cNvPr id="28" name="Branch 015 643"/>
+          <p:cNvPr id="29" name="Branch 015 644"/>
           <p:cNvSpPr/>
           <p:nvPr/>
         </p:nvSpPr>
@@ -10215,7 +10258,7 @@
       </p:sp>
       <p:sp>
         <p:nvSpPr>
-          <p:cNvPr id="29" name="Branch 016 644"/>
+          <p:cNvPr id="30" name="Branch 016 645"/>
           <p:cNvSpPr/>
           <p:nvPr/>
         </p:nvSpPr>
@@ -10258,7 +10301,7 @@
       </p:sp>
       <p:sp>
         <p:nvSpPr>
-          <p:cNvPr id="30" name="Branch 017 645"/>
+          <p:cNvPr id="31" name="Branch 017 646"/>
           <p:cNvSpPr/>
           <p:nvPr/>
         </p:nvSpPr>
@@ -10301,7 +10344,7 @@
       </p:sp>
       <p:sp>
         <p:nvSpPr>
-          <p:cNvPr id="31" name="Branch 018 646"/>
+          <p:cNvPr id="32" name="Branch 018 647"/>
           <p:cNvSpPr/>
           <p:nvPr/>
         </p:nvSpPr>
@@ -10344,7 +10387,7 @@
       </p:sp>
       <p:sp>
         <p:nvSpPr>
-          <p:cNvPr id="32" name="Branch 019 647"/>
+          <p:cNvPr id="33" name="Branch 019 648"/>
           <p:cNvSpPr/>
           <p:nvPr/>
         </p:nvSpPr>
@@ -10387,7 +10430,7 @@
       </p:sp>
       <p:sp>
         <p:nvSpPr>
-          <p:cNvPr id="33" name="Branch 020 648"/>
+          <p:cNvPr id="34" name="Branch 020 649"/>
           <p:cNvSpPr/>
           <p:nvPr/>
         </p:nvSpPr>
@@ -10430,7 +10473,7 @@
       </p:sp>
       <p:sp>
         <p:nvSpPr>
-          <p:cNvPr id="34" name="Branch 021 649"/>
+          <p:cNvPr id="35" name="Branch 021 650"/>
           <p:cNvSpPr/>
           <p:nvPr/>
         </p:nvSpPr>
@@ -10473,7 +10516,7 @@
       </p:sp>
       <p:sp>
         <p:nvSpPr>
-          <p:cNvPr id="35" name="Branch 022 650"/>
+          <p:cNvPr id="36" name="Branch 022 651"/>
           <p:cNvSpPr/>
           <p:nvPr/>
         </p:nvSpPr>
@@ -10516,7 +10559,7 @@
       </p:sp>
       <p:sp>
         <p:nvSpPr>
-          <p:cNvPr id="36" name="Card 651"/>
+          <p:cNvPr id="37" name="Card 652"/>
           <p:cNvSpPr/>
           <p:nvPr/>
         </p:nvSpPr>
@@ -10550,7 +10593,7 @@
       </p:sp>
       <p:sp>
         <p:nvSpPr>
-          <p:cNvPr id="37" name="Icon doc 652"/>
+          <p:cNvPr id="38" name="Icon doc 653"/>
           <p:cNvSpPr/>
           <p:nvPr/>
         </p:nvSpPr>
@@ -10570,7 +10613,7 @@
       </p:sp>
       <p:sp>
         <p:nvSpPr>
-          <p:cNvPr id="38" name="Glyph part 654"/>
+          <p:cNvPr id="39" name="Glyph part 655"/>
           <p:cNvSpPr/>
           <p:nvPr/>
         </p:nvSpPr>
@@ -10590,7 +10633,7 @@
       </p:sp>
       <p:sp>
         <p:nvSpPr>
-          <p:cNvPr id="39" name="Glyph part 655"/>
+          <p:cNvPr id="40" name="Glyph part 656"/>
           <p:cNvSpPr/>
           <p:nvPr/>
         </p:nvSpPr>
@@ -10610,7 +10653,7 @@
       </p:sp>
       <p:sp>
         <p:nvSpPr>
-          <p:cNvPr id="40" name="Glyph part 656"/>
+          <p:cNvPr id="41" name="Glyph part 657"/>
           <p:cNvSpPr/>
           <p:nvPr/>
         </p:nvSpPr>
@@ -10630,7 +10673,7 @@
       </p:sp>
       <p:sp>
         <p:nvSpPr>
-          <p:cNvPr id="41" name="Text 657"/>
+          <p:cNvPr id="42" name="Text 658"/>
           <p:cNvSpPr txBox="1"/>
           <p:nvPr/>
         </p:nvSpPr>
@@ -10666,7 +10709,7 @@
       </p:sp>
       <p:sp>
         <p:nvSpPr>
-          <p:cNvPr id="42" name="Text 658"/>
+          <p:cNvPr id="43" name="Text 659"/>
           <p:cNvSpPr txBox="1"/>
           <p:nvPr/>
         </p:nvSpPr>
@@ -10702,7 +10745,7 @@
       </p:sp>
       <p:sp>
         <p:nvSpPr>
-          <p:cNvPr id="43" name="Card 659"/>
+          <p:cNvPr id="44" name="Card 660"/>
           <p:cNvSpPr/>
           <p:nvPr/>
         </p:nvSpPr>
@@ -10736,7 +10779,7 @@
       </p:sp>
       <p:sp>
         <p:nvSpPr>
-          <p:cNvPr id="44" name="Icon camera 660"/>
+          <p:cNvPr id="45" name="Icon camera 661"/>
           <p:cNvSpPr/>
           <p:nvPr/>
         </p:nvSpPr>
@@ -10756,7 +10799,7 @@
       </p:sp>
       <p:sp>
         <p:nvSpPr>
-          <p:cNvPr id="45" name="Glyph part 662"/>
+          <p:cNvPr id="46" name="Glyph part 663"/>
           <p:cNvSpPr/>
           <p:nvPr/>
         </p:nvSpPr>
@@ -10776,7 +10819,7 @@
       </p:sp>
       <p:sp>
         <p:nvSpPr>
-          <p:cNvPr id="46" name="Glyph part 663"/>
+          <p:cNvPr id="47" name="Glyph part 664"/>
           <p:cNvSpPr/>
           <p:nvPr/>
         </p:nvSpPr>
@@ -10798,7 +10841,7 @@
       </p:sp>
       <p:sp>
         <p:nvSpPr>
-          <p:cNvPr id="47" name="Glyph part 664"/>
+          <p:cNvPr id="48" name="Glyph part 665"/>
           <p:cNvSpPr/>
           <p:nvPr/>
         </p:nvSpPr>
@@ -10818,7 +10861,7 @@
       </p:sp>
       <p:sp>
         <p:nvSpPr>
-          <p:cNvPr id="48" name="Glyph part 665"/>
+          <p:cNvPr id="49" name="Glyph part 666"/>
           <p:cNvSpPr/>
           <p:nvPr/>
         </p:nvSpPr>
@@ -10838,7 +10881,7 @@
       </p:sp>
       <p:sp>
         <p:nvSpPr>
-          <p:cNvPr id="49" name="Text 666"/>
+          <p:cNvPr id="50" name="Text 667"/>
           <p:cNvSpPr txBox="1"/>
           <p:nvPr/>
         </p:nvSpPr>
@@ -10874,7 +10917,7 @@
       </p:sp>
       <p:sp>
         <p:nvSpPr>
-          <p:cNvPr id="50" name="Text 667"/>
+          <p:cNvPr id="51" name="Text 668"/>
           <p:cNvSpPr txBox="1"/>
           <p:nvPr/>
         </p:nvSpPr>
@@ -10910,7 +10953,7 @@
       </p:sp>
       <p:sp>
         <p:nvSpPr>
-          <p:cNvPr id="51" name="Card 668"/>
+          <p:cNvPr id="52" name="Card 669"/>
           <p:cNvSpPr/>
           <p:nvPr/>
         </p:nvSpPr>
@@ -10944,7 +10987,7 @@
       </p:sp>
       <p:sp>
         <p:nvSpPr>
-          <p:cNvPr id="52" name="Icon clock 669"/>
+          <p:cNvPr id="53" name="Icon clock 670"/>
           <p:cNvSpPr/>
           <p:nvPr/>
         </p:nvSpPr>
@@ -10964,7 +11007,7 @@
       </p:sp>
       <p:sp>
         <p:nvSpPr>
-          <p:cNvPr id="53" name="Glyph part 671"/>
+          <p:cNvPr id="54" name="Glyph part 672"/>
           <p:cNvSpPr/>
           <p:nvPr/>
         </p:nvSpPr>
@@ -10987,7 +11030,7 @@
       </p:sp>
       <p:sp>
         <p:nvSpPr>
-          <p:cNvPr id="54" name="Glyph stroke 672"/>
+          <p:cNvPr id="55" name="Glyph stroke 673"/>
           <p:cNvSpPr/>
           <p:nvPr/>
         </p:nvSpPr>
@@ -11010,7 +11053,7 @@
       </p:sp>
       <p:sp>
         <p:nvSpPr>
-          <p:cNvPr id="55" name="Glyph stroke 673"/>
+          <p:cNvPr id="56" name="Glyph stroke 674"/>
           <p:cNvSpPr/>
           <p:nvPr/>
         </p:nvSpPr>
@@ -11033,7 +11076,7 @@
       </p:sp>
       <p:sp>
         <p:nvSpPr>
-          <p:cNvPr id="56" name="Text 674"/>
+          <p:cNvPr id="57" name="Text 675"/>
           <p:cNvSpPr txBox="1"/>
           <p:nvPr/>
         </p:nvSpPr>
@@ -11069,7 +11112,7 @@
       </p:sp>
       <p:sp>
         <p:nvSpPr>
-          <p:cNvPr id="57" name="Text 675"/>
+          <p:cNvPr id="58" name="Text 676"/>
           <p:cNvSpPr txBox="1"/>
           <p:nvPr/>
         </p:nvSpPr>
@@ -11105,7 +11148,7 @@
       </p:sp>
       <p:sp>
         <p:nvSpPr>
-          <p:cNvPr id="58" name="Card 676"/>
+          <p:cNvPr id="59" name="Card 677"/>
           <p:cNvSpPr/>
           <p:nvPr/>
         </p:nvSpPr>
@@ -11139,7 +11182,7 @@
       </p:sp>
       <p:sp>
         <p:nvSpPr>
-          <p:cNvPr id="59" name="Icon bolt 677"/>
+          <p:cNvPr id="60" name="Icon bolt 678"/>
           <p:cNvSpPr/>
           <p:nvPr/>
         </p:nvSpPr>
@@ -11159,7 +11202,7 @@
       </p:sp>
       <p:sp>
         <p:nvSpPr>
-          <p:cNvPr id="60" name="Glyph part 679"/>
+          <p:cNvPr id="61" name="Glyph part 680"/>
           <p:cNvSpPr/>
           <p:nvPr/>
         </p:nvSpPr>
@@ -11179,7 +11222,7 @@
       </p:sp>
       <p:sp>
         <p:nvSpPr>
-          <p:cNvPr id="61" name="Text 680"/>
+          <p:cNvPr id="62" name="Text 681"/>
           <p:cNvSpPr txBox="1"/>
           <p:nvPr/>
         </p:nvSpPr>
@@ -11215,7 +11258,7 @@
       </p:sp>
       <p:sp>
         <p:nvSpPr>
-          <p:cNvPr id="62" name="Text 681"/>
+          <p:cNvPr id="63" name="Text 682"/>
           <p:cNvSpPr txBox="1"/>
           <p:nvPr/>
         </p:nvSpPr>
@@ -11251,7 +11294,7 @@
       </p:sp>
       <p:sp>
         <p:nvSpPr>
-          <p:cNvPr id="63" name="Card 682"/>
+          <p:cNvPr id="64" name="Card 683"/>
           <p:cNvSpPr/>
           <p:nvPr/>
         </p:nvSpPr>
@@ -11285,7 +11328,7 @@
       </p:sp>
       <p:sp>
         <p:nvSpPr>
-          <p:cNvPr id="64" name="Icon tag 683"/>
+          <p:cNvPr id="65" name="Icon tag 684"/>
           <p:cNvSpPr/>
           <p:nvPr/>
         </p:nvSpPr>
@@ -11305,7 +11348,7 @@
       </p:sp>
       <p:sp>
         <p:nvSpPr>
-          <p:cNvPr id="65" name="Glyph part 685"/>
+          <p:cNvPr id="66" name="Glyph part 686"/>
           <p:cNvSpPr/>
           <p:nvPr/>
         </p:nvSpPr>
@@ -11325,7 +11368,7 @@
       </p:sp>
       <p:sp>
         <p:nvSpPr>
-          <p:cNvPr id="66" name="Glyph part 686"/>
+          <p:cNvPr id="67" name="Glyph part 687"/>
           <p:cNvSpPr/>
           <p:nvPr/>
         </p:nvSpPr>
@@ -11345,7 +11388,7 @@
       </p:sp>
       <p:sp>
         <p:nvSpPr>
-          <p:cNvPr id="67" name="Text 687"/>
+          <p:cNvPr id="68" name="Text 688"/>
           <p:cNvSpPr txBox="1"/>
           <p:nvPr/>
         </p:nvSpPr>
@@ -11381,7 +11424,7 @@
       </p:sp>
       <p:sp>
         <p:nvSpPr>
-          <p:cNvPr id="68" name="Text 688"/>
+          <p:cNvPr id="69" name="Text 689"/>
           <p:cNvSpPr txBox="1"/>
           <p:nvPr/>
         </p:nvSpPr>
@@ -11525,7 +11568,7 @@
       </p:sp>
       <p:sp>
         <p:nvSpPr>
-          <p:cNvPr id="4" name="Icon browser 689"/>
+          <p:cNvPr id="4" name="Icon browser 690"/>
           <p:cNvSpPr/>
           <p:nvPr/>
         </p:nvSpPr>
@@ -11545,7 +11588,7 @@
       </p:sp>
       <p:sp>
         <p:nvSpPr>
-          <p:cNvPr id="5" name="Glyph part 691"/>
+          <p:cNvPr id="5" name="Glyph part 692"/>
           <p:cNvSpPr/>
           <p:nvPr/>
         </p:nvSpPr>
@@ -11568,7 +11611,7 @@
       </p:sp>
       <p:sp>
         <p:nvSpPr>
-          <p:cNvPr id="6" name="Glyph part 692"/>
+          <p:cNvPr id="6" name="Glyph part 693"/>
           <p:cNvSpPr/>
           <p:nvPr/>
         </p:nvSpPr>
@@ -11588,7 +11631,7 @@
       </p:sp>
       <p:sp>
         <p:nvSpPr>
-          <p:cNvPr id="7" name="Text 693"/>
+          <p:cNvPr id="7" name="Text 694"/>
           <p:cNvSpPr txBox="1"/>
           <p:nvPr/>
         </p:nvSpPr>
@@ -11624,7 +11667,7 @@
       </p:sp>
       <p:sp>
         <p:nvSpPr>
-          <p:cNvPr id="8" name="Icon branch 694"/>
+          <p:cNvPr id="8" name="Icon branch 695"/>
           <p:cNvSpPr/>
           <p:nvPr/>
         </p:nvSpPr>
@@ -11644,7 +11687,7 @@
       </p:sp>
       <p:sp>
         <p:nvSpPr>
-          <p:cNvPr id="9" name="Glyph stroke 696"/>
+          <p:cNvPr id="9" name="Glyph stroke 697"/>
           <p:cNvSpPr/>
           <p:nvPr/>
         </p:nvSpPr>
@@ -11667,7 +11710,7 @@
       </p:sp>
       <p:sp>
         <p:nvSpPr>
-          <p:cNvPr id="10" name="Glyph stroke 697"/>
+          <p:cNvPr id="10" name="Glyph stroke 698"/>
           <p:cNvSpPr/>
           <p:nvPr/>
         </p:nvSpPr>
@@ -11690,7 +11733,7 @@
       </p:sp>
       <p:sp>
         <p:nvSpPr>
-          <p:cNvPr id="11" name="Glyph part 698"/>
+          <p:cNvPr id="11" name="Glyph part 699"/>
           <p:cNvSpPr/>
           <p:nvPr/>
         </p:nvSpPr>
@@ -11710,7 +11753,7 @@
       </p:sp>
       <p:sp>
         <p:nvSpPr>
-          <p:cNvPr id="12" name="Glyph part 699"/>
+          <p:cNvPr id="12" name="Glyph part 700"/>
           <p:cNvSpPr/>
           <p:nvPr/>
         </p:nvSpPr>
@@ -11730,7 +11773,7 @@
       </p:sp>
       <p:sp>
         <p:nvSpPr>
-          <p:cNvPr id="13" name="Glyph part 700"/>
+          <p:cNvPr id="13" name="Glyph part 701"/>
           <p:cNvSpPr/>
           <p:nvPr/>
         </p:nvSpPr>
@@ -11750,7 +11793,7 @@
       </p:sp>
       <p:sp>
         <p:nvSpPr>
-          <p:cNvPr id="14" name="Text 701"/>
+          <p:cNvPr id="14" name="Text 702"/>
           <p:cNvSpPr txBox="1"/>
           <p:nvPr/>
         </p:nvSpPr>
@@ -11786,7 +11829,7 @@
       </p:sp>
       <p:sp>
         <p:nvSpPr>
-          <p:cNvPr id="15" name="Icon person 702"/>
+          <p:cNvPr id="15" name="Icon person 703"/>
           <p:cNvSpPr/>
           <p:nvPr/>
         </p:nvSpPr>
@@ -11806,7 +11849,7 @@
       </p:sp>
       <p:sp>
         <p:nvSpPr>
-          <p:cNvPr id="16" name="Glyph part 704"/>
+          <p:cNvPr id="16" name="Glyph part 705"/>
           <p:cNvSpPr/>
           <p:nvPr/>
         </p:nvSpPr>
@@ -11826,7 +11869,7 @@
       </p:sp>
       <p:sp>
         <p:nvSpPr>
-          <p:cNvPr id="17" name="Glyph part 705"/>
+          <p:cNvPr id="17" name="Glyph part 706"/>
           <p:cNvSpPr/>
           <p:nvPr/>
         </p:nvSpPr>
@@ -11846,7 +11889,7 @@
       </p:sp>
       <p:sp>
         <p:nvSpPr>
-          <p:cNvPr id="18" name="Text 706"/>
+          <p:cNvPr id="18" name="Text 707"/>
           <p:cNvSpPr txBox="1"/>
           <p:nvPr/>
         </p:nvSpPr>
@@ -11882,7 +11925,7 @@
       </p:sp>
       <p:sp>
         <p:nvSpPr>
-          <p:cNvPr id="19" name="Text 707"/>
+          <p:cNvPr id="19" name="Text 708"/>
           <p:cNvSpPr txBox="1"/>
           <p:nvPr/>
         </p:nvSpPr>
@@ -15048,7 +15091,7 @@
                   <a:schemeClr val="tx2"/>
                 </a:solidFill>
               </a:rPr>
-              <a:t>Deployed by the pipeline only, and live as v0.4.1</a:t>
+              <a:t>Deployed by the pipeline only, and live as v0.4.2</a:t>
             </a:r>
             <a:endParaRPr lang="en-US" sz="1400" dirty="0"/>
           </a:p>

</xml_diff>